<commit_message>
Presentación 20 min ES/EN: QR también en «Por qué España» y transición de bloque
Co-Authored-By: Claude Opus 5.5 <noreply@anthropic.com>
Claude-Session: https://claude.ai/code/session_01YV28CAGs6ftmBuLybVXusw
</commit_message>
<xml_diff>
--- a/presentaciones/eventos-2026-10-orlando-tampa/Dream_Nest_20min_EN.pptx
+++ b/presentaciones/eventos-2026-10-orlando-tampa/Dream_Nest_20min_EN.pptx
@@ -4744,7 +4744,7 @@
   <p:clrMapOvr>
     <a:masterClrMapping/>
   </p:clrMapOvr>
-  <p:transition spd="med" dur="600">
+  <p:transition spd="med">
     <p:fade/>
   </p:transition>
 </p:sld>
@@ -4910,7 +4910,7 @@
   <p:clrMapOvr>
     <a:masterClrMapping/>
   </p:clrMapOvr>
-  <p:transition spd="med" dur="600">
+  <p:transition spd="med">
     <p:fade/>
   </p:transition>
   <p:timing>
@@ -5232,7 +5232,7 @@
   <p:clrMapOvr>
     <a:masterClrMapping/>
   </p:clrMapOvr>
-  <p:transition spd="med" dur="600">
+  <p:transition spd="med">
     <p:fade/>
   </p:transition>
   <p:timing>
@@ -5433,7 +5433,7 @@
   <p:clrMapOvr>
     <a:masterClrMapping/>
   </p:clrMapOvr>
-  <p:transition spd="med" dur="600">
+  <p:transition spd="med">
     <p:fade/>
   </p:transition>
 </p:sld>
@@ -5599,7 +5599,7 @@
   <p:clrMapOvr>
     <a:masterClrMapping/>
   </p:clrMapOvr>
-  <p:transition spd="med" dur="600">
+  <p:transition spd="med">
     <p:fade/>
   </p:transition>
   <p:timing>
@@ -5800,7 +5800,7 @@
   <p:clrMapOvr>
     <a:masterClrMapping/>
   </p:clrMapOvr>
-  <p:transition spd="med" dur="600">
+  <p:transition spd="med">
     <p:fade/>
   </p:transition>
 </p:sld>
@@ -5966,7 +5966,7 @@
   <p:clrMapOvr>
     <a:masterClrMapping/>
   </p:clrMapOvr>
-  <p:transition spd="med" dur="600">
+  <p:transition spd="med">
     <p:fade/>
   </p:transition>
   <p:timing>
@@ -6167,8 +6167,8 @@
   <p:clrMapOvr>
     <a:masterClrMapping/>
   </p:clrMapOvr>
-  <p:transition spd="med" dur="600">
-    <p:fade/>
+  <p:transition spd="slow">
+    <p:push dir="u"/>
   </p:transition>
 </p:sld>
 </file>
@@ -6212,7 +6212,7 @@
   <p:clrMapOvr>
     <a:masterClrMapping/>
   </p:clrMapOvr>
-  <p:transition spd="med" dur="600">
+  <p:transition spd="med">
     <p:fade/>
   </p:transition>
 </p:sld>
@@ -6275,7 +6275,7 @@
   <p:clrMapOvr>
     <a:masterClrMapping/>
   </p:clrMapOvr>
-  <p:transition spd="med" dur="600">
+  <p:transition spd="med">
     <p:fade/>
   </p:transition>
 </p:sld>
@@ -6320,8 +6320,8 @@
   <p:clrMapOvr>
     <a:masterClrMapping/>
   </p:clrMapOvr>
-  <p:transition spd="med" dur="600">
-    <p:fade/>
+  <p:transition spd="slow">
+    <p:push dir="u"/>
   </p:transition>
 </p:sld>
 </file>
@@ -6360,14 +6360,291 @@
           </a:prstGeom>
         </p:spPr>
       </p:pic>
+      <p:sp>
+        <p:nvSpPr>
+          <p:cNvPr id="3" name="QR card"/>
+          <p:cNvSpPr/>
+          <p:nvPr/>
+        </p:nvSpPr>
+        <p:spPr>
+          <a:xfrm>
+            <a:off x="10985500" y="63500"/>
+            <a:ext cx="1117600" cy="1371600"/>
+          </a:xfrm>
+          <a:prstGeom prst="roundRect">
+            <a:avLst>
+              <a:gd name="adj" fmla="val 8000"/>
+            </a:avLst>
+          </a:prstGeom>
+          <a:solidFill>
+            <a:srgbClr val="FFFFFF"/>
+          </a:solidFill>
+          <a:ln w="19050">
+            <a:solidFill>
+              <a:srgbClr val="A7D5BD"/>
+            </a:solidFill>
+          </a:ln>
+          <a:effectLst/>
+        </p:spPr>
+        <p:style>
+          <a:lnRef idx="1">
+            <a:schemeClr val="accent1"/>
+          </a:lnRef>
+          <a:fillRef idx="3">
+            <a:schemeClr val="accent1"/>
+          </a:fillRef>
+          <a:effectRef idx="2">
+            <a:schemeClr val="accent1"/>
+          </a:effectRef>
+          <a:fontRef idx="minor">
+            <a:schemeClr val="lt1"/>
+          </a:fontRef>
+        </p:style>
+        <p:txBody>
+          <a:bodyPr rtlCol="0" anchor="ctr"/>
+          <a:lstStyle/>
+          <a:p>
+            <a:pPr algn="ctr"/>
+          </a:p>
+        </p:txBody>
+      </p:sp>
+      <p:pic>
+        <p:nvPicPr>
+          <p:cNvPr id="4" name="QR" descr="qr-contacto-rollup.png">
+            <a:hlinkClick r:id="rId4"/>
+          </p:cNvPr>
+          <p:cNvPicPr>
+            <a:picLocks noChangeAspect="1"/>
+          </p:cNvPicPr>
+          <p:nvPr/>
+        </p:nvPicPr>
+        <p:blipFill>
+          <a:blip r:embed="rId3"/>
+          <a:stretch>
+            <a:fillRect/>
+          </a:stretch>
+        </p:blipFill>
+        <p:spPr>
+          <a:xfrm>
+            <a:off x="11112500" y="152400"/>
+            <a:ext cx="863600" cy="863600"/>
+          </a:xfrm>
+          <a:prstGeom prst="rect">
+            <a:avLst/>
+          </a:prstGeom>
+        </p:spPr>
+      </p:pic>
+      <p:sp>
+        <p:nvSpPr>
+          <p:cNvPr id="5" name="QR label"/>
+          <p:cNvSpPr txBox="1"/>
+          <p:nvPr/>
+        </p:nvSpPr>
+        <p:spPr>
+          <a:xfrm>
+            <a:off x="11023600" y="1028700"/>
+            <a:ext cx="1041400" cy="355600"/>
+          </a:xfrm>
+          <a:prstGeom prst="rect">
+            <a:avLst/>
+          </a:prstGeom>
+          <a:noFill/>
+        </p:spPr>
+        <p:txBody>
+          <a:bodyPr wrap="square" lIns="0" rIns="0" tIns="0" bIns="0">
+            <a:spAutoFit/>
+          </a:bodyPr>
+          <a:lstStyle/>
+          <a:p>
+            <a:pPr algn="ctr"/>
+            <a:r>
+              <a:rPr sz="1050" b="1">
+                <a:solidFill>
+                  <a:srgbClr val="1C3B34"/>
+                </a:solidFill>
+                <a:latin typeface="Arial"/>
+              </a:rPr>
+              <a:t>Your gift</a:t>
+            </a:r>
+          </a:p>
+          <a:p>
+            <a:pPr algn="ctr"/>
+            <a:r>
+              <a:rPr sz="900" b="0">
+                <a:solidFill>
+                  <a:srgbClr val="1C3B34"/>
+                </a:solidFill>
+                <a:latin typeface="Arial"/>
+              </a:rPr>
+              <a:t>Scan here</a:t>
+            </a:r>
+          </a:p>
+        </p:txBody>
+      </p:sp>
     </p:spTree>
   </p:cSld>
   <p:clrMapOvr>
     <a:masterClrMapping/>
   </p:clrMapOvr>
-  <p:transition spd="med" dur="600">
+  <p:transition spd="med">
     <p:fade/>
   </p:transition>
+  <p:timing>
+    <p:tnLst>
+      <p:par>
+        <p:cTn id="1" dur="indefinite" restart="never" nodeType="tmRoot">
+          <p:childTnLst>
+            <p:seq concurrent="1" nextAc="seek">
+              <p:cTn id="2" dur="indefinite" nodeType="mainSeq">
+                <p:childTnLst>
+                  <p:par>
+                    <p:cTn id="3" fill="hold">
+                      <p:stCondLst>
+                        <p:cond delay="indefinite"/>
+                        <p:cond evt="onBegin" delay="0">
+                          <p:tn val="2"/>
+                        </p:cond>
+                      </p:stCondLst>
+                      <p:childTnLst>
+                        <p:par>
+                          <p:cTn id="4" fill="hold">
+                            <p:stCondLst>
+                              <p:cond delay="500"/>
+                            </p:stCondLst>
+                            <p:childTnLst>
+                              <p:par>
+                                <p:cTn id="10" presetID="10" presetClass="entr" presetSubtype="0" fill="hold" nodeType="withEffect">
+                                  <p:stCondLst>
+                                    <p:cond delay="0"/>
+                                  </p:stCondLst>
+                                  <p:childTnLst>
+                                    <p:set>
+                                      <p:cBhvr>
+                                        <p:cTn id="11" dur="1" fill="hold">
+                                          <p:stCondLst>
+                                            <p:cond delay="0"/>
+                                          </p:stCondLst>
+                                        </p:cTn>
+                                        <p:tgtEl>
+                                          <p:spTgt spid="3"/>
+                                        </p:tgtEl>
+                                        <p:attrNameLst>
+                                          <p:attrName>style.visibility</p:attrName>
+                                        </p:attrNameLst>
+                                      </p:cBhvr>
+                                      <p:to>
+                                        <p:strVal val="visible"/>
+                                      </p:to>
+                                    </p:set>
+                                    <p:animEffect transition="in" filter="fade">
+                                      <p:cBhvr>
+                                        <p:cTn id="12" dur="700"/>
+                                        <p:tgtEl>
+                                          <p:spTgt spid="3"/>
+                                        </p:tgtEl>
+                                      </p:cBhvr>
+                                    </p:animEffect>
+                                  </p:childTnLst>
+                                </p:cTn>
+                              </p:par>
+                              <p:par>
+                                <p:cTn id="13" presetID="10" presetClass="entr" presetSubtype="0" fill="hold" nodeType="withEffect">
+                                  <p:stCondLst>
+                                    <p:cond delay="0"/>
+                                  </p:stCondLst>
+                                  <p:childTnLst>
+                                    <p:set>
+                                      <p:cBhvr>
+                                        <p:cTn id="14" dur="1" fill="hold">
+                                          <p:stCondLst>
+                                            <p:cond delay="0"/>
+                                          </p:stCondLst>
+                                        </p:cTn>
+                                        <p:tgtEl>
+                                          <p:spTgt spid="4"/>
+                                        </p:tgtEl>
+                                        <p:attrNameLst>
+                                          <p:attrName>style.visibility</p:attrName>
+                                        </p:attrNameLst>
+                                      </p:cBhvr>
+                                      <p:to>
+                                        <p:strVal val="visible"/>
+                                      </p:to>
+                                    </p:set>
+                                    <p:animEffect transition="in" filter="fade">
+                                      <p:cBhvr>
+                                        <p:cTn id="15" dur="700"/>
+                                        <p:tgtEl>
+                                          <p:spTgt spid="4"/>
+                                        </p:tgtEl>
+                                      </p:cBhvr>
+                                    </p:animEffect>
+                                  </p:childTnLst>
+                                </p:cTn>
+                              </p:par>
+                              <p:par>
+                                <p:cTn id="16" presetID="10" presetClass="entr" presetSubtype="0" fill="hold" nodeType="withEffect">
+                                  <p:stCondLst>
+                                    <p:cond delay="0"/>
+                                  </p:stCondLst>
+                                  <p:childTnLst>
+                                    <p:set>
+                                      <p:cBhvr>
+                                        <p:cTn id="17" dur="1" fill="hold">
+                                          <p:stCondLst>
+                                            <p:cond delay="0"/>
+                                          </p:stCondLst>
+                                        </p:cTn>
+                                        <p:tgtEl>
+                                          <p:spTgt spid="5"/>
+                                        </p:tgtEl>
+                                        <p:attrNameLst>
+                                          <p:attrName>style.visibility</p:attrName>
+                                        </p:attrNameLst>
+                                      </p:cBhvr>
+                                      <p:to>
+                                        <p:strVal val="visible"/>
+                                      </p:to>
+                                    </p:set>
+                                    <p:animEffect transition="in" filter="fade">
+                                      <p:cBhvr>
+                                        <p:cTn id="18" dur="700"/>
+                                        <p:tgtEl>
+                                          <p:spTgt spid="5"/>
+                                        </p:tgtEl>
+                                      </p:cBhvr>
+                                    </p:animEffect>
+                                  </p:childTnLst>
+                                </p:cTn>
+                              </p:par>
+                            </p:childTnLst>
+                          </p:cTn>
+                        </p:par>
+                      </p:childTnLst>
+                    </p:cTn>
+                  </p:par>
+                </p:childTnLst>
+              </p:cTn>
+              <p:prevCondLst>
+                <p:cond evt="onPrev" delay="0">
+                  <p:tgtEl>
+                    <p:sldTgt/>
+                  </p:tgtEl>
+                </p:cond>
+              </p:prevCondLst>
+              <p:nextCondLst>
+                <p:cond evt="onNext" delay="0">
+                  <p:tgtEl>
+                    <p:sldTgt/>
+                  </p:tgtEl>
+                </p:cond>
+              </p:nextCondLst>
+            </p:seq>
+          </p:childTnLst>
+        </p:cTn>
+      </p:par>
+    </p:tnLst>
+  </p:timing>
 </p:sld>
 </file>
 
@@ -6410,7 +6687,7 @@
   <p:clrMapOvr>
     <a:masterClrMapping/>
   </p:clrMapOvr>
-  <p:transition spd="med" dur="600">
+  <p:transition spd="med">
     <p:fade/>
   </p:transition>
 </p:sld>
@@ -6455,8 +6732,8 @@
   <p:clrMapOvr>
     <a:masterClrMapping/>
   </p:clrMapOvr>
-  <p:transition spd="med" dur="600">
-    <p:fade/>
+  <p:transition spd="slow">
+    <p:push dir="u"/>
   </p:transition>
 </p:sld>
 </file>
@@ -6621,8 +6898,8 @@
   <p:clrMapOvr>
     <a:masterClrMapping/>
   </p:clrMapOvr>
-  <p:transition spd="med" dur="600">
-    <p:fade/>
+  <p:transition spd="slow">
+    <p:push dir="u"/>
   </p:transition>
   <p:timing>
     <p:tnLst>
@@ -6943,7 +7220,7 @@
   <p:clrMapOvr>
     <a:masterClrMapping/>
   </p:clrMapOvr>
-  <p:transition spd="med" dur="600">
+  <p:transition spd="med">
     <p:fade/>
   </p:transition>
   <p:timing>
@@ -7265,7 +7542,7 @@
   <p:clrMapOvr>
     <a:masterClrMapping/>
   </p:clrMapOvr>
-  <p:transition spd="med" dur="600">
+  <p:transition spd="med">
     <p:fade/>
   </p:transition>
   <p:timing>
@@ -7587,7 +7864,7 @@
   <p:clrMapOvr>
     <a:masterClrMapping/>
   </p:clrMapOvr>
-  <p:transition spd="med" dur="600">
+  <p:transition spd="med">
     <p:fade/>
   </p:transition>
   <p:timing>

</xml_diff>

<commit_message>
Presentación 20 min ES/EN: un solo clic por diapositiva (sin animación propia del QR)
Co-Authored-By: Claude Opus 5.5 <noreply@anthropic.com>
Claude-Session: https://claude.ai/code/session_01YV28CAGs6ftmBuLybVXusw
</commit_message>
<xml_diff>
--- a/presentaciones/eventos-2026-10-orlando-tampa/Dream_Nest_20min_EN.pptx
+++ b/presentaciones/eventos-2026-10-orlando-tampa/Dream_Nest_20min_EN.pptx
@@ -4913,162 +4913,6 @@
   <p:transition spd="med">
     <p:fade/>
   </p:transition>
-  <p:timing>
-    <p:tnLst>
-      <p:par>
-        <p:cTn id="1" dur="indefinite" restart="never" nodeType="tmRoot">
-          <p:childTnLst>
-            <p:seq concurrent="1" nextAc="seek">
-              <p:cTn id="2" dur="indefinite" nodeType="mainSeq">
-                <p:childTnLst>
-                  <p:par>
-                    <p:cTn id="3" fill="hold">
-                      <p:stCondLst>
-                        <p:cond delay="indefinite"/>
-                        <p:cond evt="onBegin" delay="0">
-                          <p:tn val="2"/>
-                        </p:cond>
-                      </p:stCondLst>
-                      <p:childTnLst>
-                        <p:par>
-                          <p:cTn id="4" fill="hold">
-                            <p:stCondLst>
-                              <p:cond delay="500"/>
-                            </p:stCondLst>
-                            <p:childTnLst>
-                              <p:par>
-                                <p:cTn id="10" presetID="10" presetClass="entr" presetSubtype="0" fill="hold" nodeType="withEffect">
-                                  <p:stCondLst>
-                                    <p:cond delay="0"/>
-                                  </p:stCondLst>
-                                  <p:childTnLst>
-                                    <p:set>
-                                      <p:cBhvr>
-                                        <p:cTn id="11" dur="1" fill="hold">
-                                          <p:stCondLst>
-                                            <p:cond delay="0"/>
-                                          </p:stCondLst>
-                                        </p:cTn>
-                                        <p:tgtEl>
-                                          <p:spTgt spid="3"/>
-                                        </p:tgtEl>
-                                        <p:attrNameLst>
-                                          <p:attrName>style.visibility</p:attrName>
-                                        </p:attrNameLst>
-                                      </p:cBhvr>
-                                      <p:to>
-                                        <p:strVal val="visible"/>
-                                      </p:to>
-                                    </p:set>
-                                    <p:animEffect transition="in" filter="fade">
-                                      <p:cBhvr>
-                                        <p:cTn id="12" dur="700"/>
-                                        <p:tgtEl>
-                                          <p:spTgt spid="3"/>
-                                        </p:tgtEl>
-                                      </p:cBhvr>
-                                    </p:animEffect>
-                                  </p:childTnLst>
-                                </p:cTn>
-                              </p:par>
-                              <p:par>
-                                <p:cTn id="13" presetID="10" presetClass="entr" presetSubtype="0" fill="hold" nodeType="withEffect">
-                                  <p:stCondLst>
-                                    <p:cond delay="0"/>
-                                  </p:stCondLst>
-                                  <p:childTnLst>
-                                    <p:set>
-                                      <p:cBhvr>
-                                        <p:cTn id="14" dur="1" fill="hold">
-                                          <p:stCondLst>
-                                            <p:cond delay="0"/>
-                                          </p:stCondLst>
-                                        </p:cTn>
-                                        <p:tgtEl>
-                                          <p:spTgt spid="4"/>
-                                        </p:tgtEl>
-                                        <p:attrNameLst>
-                                          <p:attrName>style.visibility</p:attrName>
-                                        </p:attrNameLst>
-                                      </p:cBhvr>
-                                      <p:to>
-                                        <p:strVal val="visible"/>
-                                      </p:to>
-                                    </p:set>
-                                    <p:animEffect transition="in" filter="fade">
-                                      <p:cBhvr>
-                                        <p:cTn id="15" dur="700"/>
-                                        <p:tgtEl>
-                                          <p:spTgt spid="4"/>
-                                        </p:tgtEl>
-                                      </p:cBhvr>
-                                    </p:animEffect>
-                                  </p:childTnLst>
-                                </p:cTn>
-                              </p:par>
-                              <p:par>
-                                <p:cTn id="16" presetID="10" presetClass="entr" presetSubtype="0" fill="hold" nodeType="withEffect">
-                                  <p:stCondLst>
-                                    <p:cond delay="0"/>
-                                  </p:stCondLst>
-                                  <p:childTnLst>
-                                    <p:set>
-                                      <p:cBhvr>
-                                        <p:cTn id="17" dur="1" fill="hold">
-                                          <p:stCondLst>
-                                            <p:cond delay="0"/>
-                                          </p:stCondLst>
-                                        </p:cTn>
-                                        <p:tgtEl>
-                                          <p:spTgt spid="5"/>
-                                        </p:tgtEl>
-                                        <p:attrNameLst>
-                                          <p:attrName>style.visibility</p:attrName>
-                                        </p:attrNameLst>
-                                      </p:cBhvr>
-                                      <p:to>
-                                        <p:strVal val="visible"/>
-                                      </p:to>
-                                    </p:set>
-                                    <p:animEffect transition="in" filter="fade">
-                                      <p:cBhvr>
-                                        <p:cTn id="18" dur="700"/>
-                                        <p:tgtEl>
-                                          <p:spTgt spid="5"/>
-                                        </p:tgtEl>
-                                      </p:cBhvr>
-                                    </p:animEffect>
-                                  </p:childTnLst>
-                                </p:cTn>
-                              </p:par>
-                            </p:childTnLst>
-                          </p:cTn>
-                        </p:par>
-                      </p:childTnLst>
-                    </p:cTn>
-                  </p:par>
-                </p:childTnLst>
-              </p:cTn>
-              <p:prevCondLst>
-                <p:cond evt="onPrev" delay="0">
-                  <p:tgtEl>
-                    <p:sldTgt/>
-                  </p:tgtEl>
-                </p:cond>
-              </p:prevCondLst>
-              <p:nextCondLst>
-                <p:cond evt="onNext" delay="0">
-                  <p:tgtEl>
-                    <p:sldTgt/>
-                  </p:tgtEl>
-                </p:cond>
-              </p:nextCondLst>
-            </p:seq>
-          </p:childTnLst>
-        </p:cTn>
-      </p:par>
-    </p:tnLst>
-  </p:timing>
 </p:sld>
 </file>
 
@@ -5235,162 +5079,6 @@
   <p:transition spd="med">
     <p:fade/>
   </p:transition>
-  <p:timing>
-    <p:tnLst>
-      <p:par>
-        <p:cTn id="1" dur="indefinite" restart="never" nodeType="tmRoot">
-          <p:childTnLst>
-            <p:seq concurrent="1" nextAc="seek">
-              <p:cTn id="2" dur="indefinite" nodeType="mainSeq">
-                <p:childTnLst>
-                  <p:par>
-                    <p:cTn id="3" fill="hold">
-                      <p:stCondLst>
-                        <p:cond delay="indefinite"/>
-                        <p:cond evt="onBegin" delay="0">
-                          <p:tn val="2"/>
-                        </p:cond>
-                      </p:stCondLst>
-                      <p:childTnLst>
-                        <p:par>
-                          <p:cTn id="4" fill="hold">
-                            <p:stCondLst>
-                              <p:cond delay="500"/>
-                            </p:stCondLst>
-                            <p:childTnLst>
-                              <p:par>
-                                <p:cTn id="10" presetID="10" presetClass="entr" presetSubtype="0" fill="hold" nodeType="withEffect">
-                                  <p:stCondLst>
-                                    <p:cond delay="0"/>
-                                  </p:stCondLst>
-                                  <p:childTnLst>
-                                    <p:set>
-                                      <p:cBhvr>
-                                        <p:cTn id="11" dur="1" fill="hold">
-                                          <p:stCondLst>
-                                            <p:cond delay="0"/>
-                                          </p:stCondLst>
-                                        </p:cTn>
-                                        <p:tgtEl>
-                                          <p:spTgt spid="3"/>
-                                        </p:tgtEl>
-                                        <p:attrNameLst>
-                                          <p:attrName>style.visibility</p:attrName>
-                                        </p:attrNameLst>
-                                      </p:cBhvr>
-                                      <p:to>
-                                        <p:strVal val="visible"/>
-                                      </p:to>
-                                    </p:set>
-                                    <p:animEffect transition="in" filter="fade">
-                                      <p:cBhvr>
-                                        <p:cTn id="12" dur="700"/>
-                                        <p:tgtEl>
-                                          <p:spTgt spid="3"/>
-                                        </p:tgtEl>
-                                      </p:cBhvr>
-                                    </p:animEffect>
-                                  </p:childTnLst>
-                                </p:cTn>
-                              </p:par>
-                              <p:par>
-                                <p:cTn id="13" presetID="10" presetClass="entr" presetSubtype="0" fill="hold" nodeType="withEffect">
-                                  <p:stCondLst>
-                                    <p:cond delay="0"/>
-                                  </p:stCondLst>
-                                  <p:childTnLst>
-                                    <p:set>
-                                      <p:cBhvr>
-                                        <p:cTn id="14" dur="1" fill="hold">
-                                          <p:stCondLst>
-                                            <p:cond delay="0"/>
-                                          </p:stCondLst>
-                                        </p:cTn>
-                                        <p:tgtEl>
-                                          <p:spTgt spid="4"/>
-                                        </p:tgtEl>
-                                        <p:attrNameLst>
-                                          <p:attrName>style.visibility</p:attrName>
-                                        </p:attrNameLst>
-                                      </p:cBhvr>
-                                      <p:to>
-                                        <p:strVal val="visible"/>
-                                      </p:to>
-                                    </p:set>
-                                    <p:animEffect transition="in" filter="fade">
-                                      <p:cBhvr>
-                                        <p:cTn id="15" dur="700"/>
-                                        <p:tgtEl>
-                                          <p:spTgt spid="4"/>
-                                        </p:tgtEl>
-                                      </p:cBhvr>
-                                    </p:animEffect>
-                                  </p:childTnLst>
-                                </p:cTn>
-                              </p:par>
-                              <p:par>
-                                <p:cTn id="16" presetID="10" presetClass="entr" presetSubtype="0" fill="hold" nodeType="withEffect">
-                                  <p:stCondLst>
-                                    <p:cond delay="0"/>
-                                  </p:stCondLst>
-                                  <p:childTnLst>
-                                    <p:set>
-                                      <p:cBhvr>
-                                        <p:cTn id="17" dur="1" fill="hold">
-                                          <p:stCondLst>
-                                            <p:cond delay="0"/>
-                                          </p:stCondLst>
-                                        </p:cTn>
-                                        <p:tgtEl>
-                                          <p:spTgt spid="5"/>
-                                        </p:tgtEl>
-                                        <p:attrNameLst>
-                                          <p:attrName>style.visibility</p:attrName>
-                                        </p:attrNameLst>
-                                      </p:cBhvr>
-                                      <p:to>
-                                        <p:strVal val="visible"/>
-                                      </p:to>
-                                    </p:set>
-                                    <p:animEffect transition="in" filter="fade">
-                                      <p:cBhvr>
-                                        <p:cTn id="18" dur="700"/>
-                                        <p:tgtEl>
-                                          <p:spTgt spid="5"/>
-                                        </p:tgtEl>
-                                      </p:cBhvr>
-                                    </p:animEffect>
-                                  </p:childTnLst>
-                                </p:cTn>
-                              </p:par>
-                            </p:childTnLst>
-                          </p:cTn>
-                        </p:par>
-                      </p:childTnLst>
-                    </p:cTn>
-                  </p:par>
-                </p:childTnLst>
-              </p:cTn>
-              <p:prevCondLst>
-                <p:cond evt="onPrev" delay="0">
-                  <p:tgtEl>
-                    <p:sldTgt/>
-                  </p:tgtEl>
-                </p:cond>
-              </p:prevCondLst>
-              <p:nextCondLst>
-                <p:cond evt="onNext" delay="0">
-                  <p:tgtEl>
-                    <p:sldTgt/>
-                  </p:tgtEl>
-                </p:cond>
-              </p:nextCondLst>
-            </p:seq>
-          </p:childTnLst>
-        </p:cTn>
-      </p:par>
-    </p:tnLst>
-  </p:timing>
 </p:sld>
 </file>
 
@@ -5602,162 +5290,6 @@
   <p:transition spd="med">
     <p:fade/>
   </p:transition>
-  <p:timing>
-    <p:tnLst>
-      <p:par>
-        <p:cTn id="1" dur="indefinite" restart="never" nodeType="tmRoot">
-          <p:childTnLst>
-            <p:seq concurrent="1" nextAc="seek">
-              <p:cTn id="2" dur="indefinite" nodeType="mainSeq">
-                <p:childTnLst>
-                  <p:par>
-                    <p:cTn id="3" fill="hold">
-                      <p:stCondLst>
-                        <p:cond delay="indefinite"/>
-                        <p:cond evt="onBegin" delay="0">
-                          <p:tn val="2"/>
-                        </p:cond>
-                      </p:stCondLst>
-                      <p:childTnLst>
-                        <p:par>
-                          <p:cTn id="4" fill="hold">
-                            <p:stCondLst>
-                              <p:cond delay="500"/>
-                            </p:stCondLst>
-                            <p:childTnLst>
-                              <p:par>
-                                <p:cTn id="10" presetID="10" presetClass="entr" presetSubtype="0" fill="hold" nodeType="withEffect">
-                                  <p:stCondLst>
-                                    <p:cond delay="0"/>
-                                  </p:stCondLst>
-                                  <p:childTnLst>
-                                    <p:set>
-                                      <p:cBhvr>
-                                        <p:cTn id="11" dur="1" fill="hold">
-                                          <p:stCondLst>
-                                            <p:cond delay="0"/>
-                                          </p:stCondLst>
-                                        </p:cTn>
-                                        <p:tgtEl>
-                                          <p:spTgt spid="3"/>
-                                        </p:tgtEl>
-                                        <p:attrNameLst>
-                                          <p:attrName>style.visibility</p:attrName>
-                                        </p:attrNameLst>
-                                      </p:cBhvr>
-                                      <p:to>
-                                        <p:strVal val="visible"/>
-                                      </p:to>
-                                    </p:set>
-                                    <p:animEffect transition="in" filter="fade">
-                                      <p:cBhvr>
-                                        <p:cTn id="12" dur="700"/>
-                                        <p:tgtEl>
-                                          <p:spTgt spid="3"/>
-                                        </p:tgtEl>
-                                      </p:cBhvr>
-                                    </p:animEffect>
-                                  </p:childTnLst>
-                                </p:cTn>
-                              </p:par>
-                              <p:par>
-                                <p:cTn id="13" presetID="10" presetClass="entr" presetSubtype="0" fill="hold" nodeType="withEffect">
-                                  <p:stCondLst>
-                                    <p:cond delay="0"/>
-                                  </p:stCondLst>
-                                  <p:childTnLst>
-                                    <p:set>
-                                      <p:cBhvr>
-                                        <p:cTn id="14" dur="1" fill="hold">
-                                          <p:stCondLst>
-                                            <p:cond delay="0"/>
-                                          </p:stCondLst>
-                                        </p:cTn>
-                                        <p:tgtEl>
-                                          <p:spTgt spid="4"/>
-                                        </p:tgtEl>
-                                        <p:attrNameLst>
-                                          <p:attrName>style.visibility</p:attrName>
-                                        </p:attrNameLst>
-                                      </p:cBhvr>
-                                      <p:to>
-                                        <p:strVal val="visible"/>
-                                      </p:to>
-                                    </p:set>
-                                    <p:animEffect transition="in" filter="fade">
-                                      <p:cBhvr>
-                                        <p:cTn id="15" dur="700"/>
-                                        <p:tgtEl>
-                                          <p:spTgt spid="4"/>
-                                        </p:tgtEl>
-                                      </p:cBhvr>
-                                    </p:animEffect>
-                                  </p:childTnLst>
-                                </p:cTn>
-                              </p:par>
-                              <p:par>
-                                <p:cTn id="16" presetID="10" presetClass="entr" presetSubtype="0" fill="hold" nodeType="withEffect">
-                                  <p:stCondLst>
-                                    <p:cond delay="0"/>
-                                  </p:stCondLst>
-                                  <p:childTnLst>
-                                    <p:set>
-                                      <p:cBhvr>
-                                        <p:cTn id="17" dur="1" fill="hold">
-                                          <p:stCondLst>
-                                            <p:cond delay="0"/>
-                                          </p:stCondLst>
-                                        </p:cTn>
-                                        <p:tgtEl>
-                                          <p:spTgt spid="5"/>
-                                        </p:tgtEl>
-                                        <p:attrNameLst>
-                                          <p:attrName>style.visibility</p:attrName>
-                                        </p:attrNameLst>
-                                      </p:cBhvr>
-                                      <p:to>
-                                        <p:strVal val="visible"/>
-                                      </p:to>
-                                    </p:set>
-                                    <p:animEffect transition="in" filter="fade">
-                                      <p:cBhvr>
-                                        <p:cTn id="18" dur="700"/>
-                                        <p:tgtEl>
-                                          <p:spTgt spid="5"/>
-                                        </p:tgtEl>
-                                      </p:cBhvr>
-                                    </p:animEffect>
-                                  </p:childTnLst>
-                                </p:cTn>
-                              </p:par>
-                            </p:childTnLst>
-                          </p:cTn>
-                        </p:par>
-                      </p:childTnLst>
-                    </p:cTn>
-                  </p:par>
-                </p:childTnLst>
-              </p:cTn>
-              <p:prevCondLst>
-                <p:cond evt="onPrev" delay="0">
-                  <p:tgtEl>
-                    <p:sldTgt/>
-                  </p:tgtEl>
-                </p:cond>
-              </p:prevCondLst>
-              <p:nextCondLst>
-                <p:cond evt="onNext" delay="0">
-                  <p:tgtEl>
-                    <p:sldTgt/>
-                  </p:tgtEl>
-                </p:cond>
-              </p:nextCondLst>
-            </p:seq>
-          </p:childTnLst>
-        </p:cTn>
-      </p:par>
-    </p:tnLst>
-  </p:timing>
 </p:sld>
 </file>
 
@@ -5969,162 +5501,6 @@
   <p:transition spd="med">
     <p:fade/>
   </p:transition>
-  <p:timing>
-    <p:tnLst>
-      <p:par>
-        <p:cTn id="1" dur="indefinite" restart="never" nodeType="tmRoot">
-          <p:childTnLst>
-            <p:seq concurrent="1" nextAc="seek">
-              <p:cTn id="2" dur="indefinite" nodeType="mainSeq">
-                <p:childTnLst>
-                  <p:par>
-                    <p:cTn id="3" fill="hold">
-                      <p:stCondLst>
-                        <p:cond delay="indefinite"/>
-                        <p:cond evt="onBegin" delay="0">
-                          <p:tn val="2"/>
-                        </p:cond>
-                      </p:stCondLst>
-                      <p:childTnLst>
-                        <p:par>
-                          <p:cTn id="4" fill="hold">
-                            <p:stCondLst>
-                              <p:cond delay="500"/>
-                            </p:stCondLst>
-                            <p:childTnLst>
-                              <p:par>
-                                <p:cTn id="10" presetID="10" presetClass="entr" presetSubtype="0" fill="hold" nodeType="withEffect">
-                                  <p:stCondLst>
-                                    <p:cond delay="0"/>
-                                  </p:stCondLst>
-                                  <p:childTnLst>
-                                    <p:set>
-                                      <p:cBhvr>
-                                        <p:cTn id="11" dur="1" fill="hold">
-                                          <p:stCondLst>
-                                            <p:cond delay="0"/>
-                                          </p:stCondLst>
-                                        </p:cTn>
-                                        <p:tgtEl>
-                                          <p:spTgt spid="3"/>
-                                        </p:tgtEl>
-                                        <p:attrNameLst>
-                                          <p:attrName>style.visibility</p:attrName>
-                                        </p:attrNameLst>
-                                      </p:cBhvr>
-                                      <p:to>
-                                        <p:strVal val="visible"/>
-                                      </p:to>
-                                    </p:set>
-                                    <p:animEffect transition="in" filter="fade">
-                                      <p:cBhvr>
-                                        <p:cTn id="12" dur="700"/>
-                                        <p:tgtEl>
-                                          <p:spTgt spid="3"/>
-                                        </p:tgtEl>
-                                      </p:cBhvr>
-                                    </p:animEffect>
-                                  </p:childTnLst>
-                                </p:cTn>
-                              </p:par>
-                              <p:par>
-                                <p:cTn id="13" presetID="10" presetClass="entr" presetSubtype="0" fill="hold" nodeType="withEffect">
-                                  <p:stCondLst>
-                                    <p:cond delay="0"/>
-                                  </p:stCondLst>
-                                  <p:childTnLst>
-                                    <p:set>
-                                      <p:cBhvr>
-                                        <p:cTn id="14" dur="1" fill="hold">
-                                          <p:stCondLst>
-                                            <p:cond delay="0"/>
-                                          </p:stCondLst>
-                                        </p:cTn>
-                                        <p:tgtEl>
-                                          <p:spTgt spid="4"/>
-                                        </p:tgtEl>
-                                        <p:attrNameLst>
-                                          <p:attrName>style.visibility</p:attrName>
-                                        </p:attrNameLst>
-                                      </p:cBhvr>
-                                      <p:to>
-                                        <p:strVal val="visible"/>
-                                      </p:to>
-                                    </p:set>
-                                    <p:animEffect transition="in" filter="fade">
-                                      <p:cBhvr>
-                                        <p:cTn id="15" dur="700"/>
-                                        <p:tgtEl>
-                                          <p:spTgt spid="4"/>
-                                        </p:tgtEl>
-                                      </p:cBhvr>
-                                    </p:animEffect>
-                                  </p:childTnLst>
-                                </p:cTn>
-                              </p:par>
-                              <p:par>
-                                <p:cTn id="16" presetID="10" presetClass="entr" presetSubtype="0" fill="hold" nodeType="withEffect">
-                                  <p:stCondLst>
-                                    <p:cond delay="0"/>
-                                  </p:stCondLst>
-                                  <p:childTnLst>
-                                    <p:set>
-                                      <p:cBhvr>
-                                        <p:cTn id="17" dur="1" fill="hold">
-                                          <p:stCondLst>
-                                            <p:cond delay="0"/>
-                                          </p:stCondLst>
-                                        </p:cTn>
-                                        <p:tgtEl>
-                                          <p:spTgt spid="5"/>
-                                        </p:tgtEl>
-                                        <p:attrNameLst>
-                                          <p:attrName>style.visibility</p:attrName>
-                                        </p:attrNameLst>
-                                      </p:cBhvr>
-                                      <p:to>
-                                        <p:strVal val="visible"/>
-                                      </p:to>
-                                    </p:set>
-                                    <p:animEffect transition="in" filter="fade">
-                                      <p:cBhvr>
-                                        <p:cTn id="18" dur="700"/>
-                                        <p:tgtEl>
-                                          <p:spTgt spid="5"/>
-                                        </p:tgtEl>
-                                      </p:cBhvr>
-                                    </p:animEffect>
-                                  </p:childTnLst>
-                                </p:cTn>
-                              </p:par>
-                            </p:childTnLst>
-                          </p:cTn>
-                        </p:par>
-                      </p:childTnLst>
-                    </p:cTn>
-                  </p:par>
-                </p:childTnLst>
-              </p:cTn>
-              <p:prevCondLst>
-                <p:cond evt="onPrev" delay="0">
-                  <p:tgtEl>
-                    <p:sldTgt/>
-                  </p:tgtEl>
-                </p:cond>
-              </p:prevCondLst>
-              <p:nextCondLst>
-                <p:cond evt="onNext" delay="0">
-                  <p:tgtEl>
-                    <p:sldTgt/>
-                  </p:tgtEl>
-                </p:cond>
-              </p:nextCondLst>
-            </p:seq>
-          </p:childTnLst>
-        </p:cTn>
-      </p:par>
-    </p:tnLst>
-  </p:timing>
 </p:sld>
 </file>
 
@@ -6489,162 +5865,6 @@
   <p:transition spd="med">
     <p:fade/>
   </p:transition>
-  <p:timing>
-    <p:tnLst>
-      <p:par>
-        <p:cTn id="1" dur="indefinite" restart="never" nodeType="tmRoot">
-          <p:childTnLst>
-            <p:seq concurrent="1" nextAc="seek">
-              <p:cTn id="2" dur="indefinite" nodeType="mainSeq">
-                <p:childTnLst>
-                  <p:par>
-                    <p:cTn id="3" fill="hold">
-                      <p:stCondLst>
-                        <p:cond delay="indefinite"/>
-                        <p:cond evt="onBegin" delay="0">
-                          <p:tn val="2"/>
-                        </p:cond>
-                      </p:stCondLst>
-                      <p:childTnLst>
-                        <p:par>
-                          <p:cTn id="4" fill="hold">
-                            <p:stCondLst>
-                              <p:cond delay="500"/>
-                            </p:stCondLst>
-                            <p:childTnLst>
-                              <p:par>
-                                <p:cTn id="10" presetID="10" presetClass="entr" presetSubtype="0" fill="hold" nodeType="withEffect">
-                                  <p:stCondLst>
-                                    <p:cond delay="0"/>
-                                  </p:stCondLst>
-                                  <p:childTnLst>
-                                    <p:set>
-                                      <p:cBhvr>
-                                        <p:cTn id="11" dur="1" fill="hold">
-                                          <p:stCondLst>
-                                            <p:cond delay="0"/>
-                                          </p:stCondLst>
-                                        </p:cTn>
-                                        <p:tgtEl>
-                                          <p:spTgt spid="3"/>
-                                        </p:tgtEl>
-                                        <p:attrNameLst>
-                                          <p:attrName>style.visibility</p:attrName>
-                                        </p:attrNameLst>
-                                      </p:cBhvr>
-                                      <p:to>
-                                        <p:strVal val="visible"/>
-                                      </p:to>
-                                    </p:set>
-                                    <p:animEffect transition="in" filter="fade">
-                                      <p:cBhvr>
-                                        <p:cTn id="12" dur="700"/>
-                                        <p:tgtEl>
-                                          <p:spTgt spid="3"/>
-                                        </p:tgtEl>
-                                      </p:cBhvr>
-                                    </p:animEffect>
-                                  </p:childTnLst>
-                                </p:cTn>
-                              </p:par>
-                              <p:par>
-                                <p:cTn id="13" presetID="10" presetClass="entr" presetSubtype="0" fill="hold" nodeType="withEffect">
-                                  <p:stCondLst>
-                                    <p:cond delay="0"/>
-                                  </p:stCondLst>
-                                  <p:childTnLst>
-                                    <p:set>
-                                      <p:cBhvr>
-                                        <p:cTn id="14" dur="1" fill="hold">
-                                          <p:stCondLst>
-                                            <p:cond delay="0"/>
-                                          </p:stCondLst>
-                                        </p:cTn>
-                                        <p:tgtEl>
-                                          <p:spTgt spid="4"/>
-                                        </p:tgtEl>
-                                        <p:attrNameLst>
-                                          <p:attrName>style.visibility</p:attrName>
-                                        </p:attrNameLst>
-                                      </p:cBhvr>
-                                      <p:to>
-                                        <p:strVal val="visible"/>
-                                      </p:to>
-                                    </p:set>
-                                    <p:animEffect transition="in" filter="fade">
-                                      <p:cBhvr>
-                                        <p:cTn id="15" dur="700"/>
-                                        <p:tgtEl>
-                                          <p:spTgt spid="4"/>
-                                        </p:tgtEl>
-                                      </p:cBhvr>
-                                    </p:animEffect>
-                                  </p:childTnLst>
-                                </p:cTn>
-                              </p:par>
-                              <p:par>
-                                <p:cTn id="16" presetID="10" presetClass="entr" presetSubtype="0" fill="hold" nodeType="withEffect">
-                                  <p:stCondLst>
-                                    <p:cond delay="0"/>
-                                  </p:stCondLst>
-                                  <p:childTnLst>
-                                    <p:set>
-                                      <p:cBhvr>
-                                        <p:cTn id="17" dur="1" fill="hold">
-                                          <p:stCondLst>
-                                            <p:cond delay="0"/>
-                                          </p:stCondLst>
-                                        </p:cTn>
-                                        <p:tgtEl>
-                                          <p:spTgt spid="5"/>
-                                        </p:tgtEl>
-                                        <p:attrNameLst>
-                                          <p:attrName>style.visibility</p:attrName>
-                                        </p:attrNameLst>
-                                      </p:cBhvr>
-                                      <p:to>
-                                        <p:strVal val="visible"/>
-                                      </p:to>
-                                    </p:set>
-                                    <p:animEffect transition="in" filter="fade">
-                                      <p:cBhvr>
-                                        <p:cTn id="18" dur="700"/>
-                                        <p:tgtEl>
-                                          <p:spTgt spid="5"/>
-                                        </p:tgtEl>
-                                      </p:cBhvr>
-                                    </p:animEffect>
-                                  </p:childTnLst>
-                                </p:cTn>
-                              </p:par>
-                            </p:childTnLst>
-                          </p:cTn>
-                        </p:par>
-                      </p:childTnLst>
-                    </p:cTn>
-                  </p:par>
-                </p:childTnLst>
-              </p:cTn>
-              <p:prevCondLst>
-                <p:cond evt="onPrev" delay="0">
-                  <p:tgtEl>
-                    <p:sldTgt/>
-                  </p:tgtEl>
-                </p:cond>
-              </p:prevCondLst>
-              <p:nextCondLst>
-                <p:cond evt="onNext" delay="0">
-                  <p:tgtEl>
-                    <p:sldTgt/>
-                  </p:tgtEl>
-                </p:cond>
-              </p:nextCondLst>
-            </p:seq>
-          </p:childTnLst>
-        </p:cTn>
-      </p:par>
-    </p:tnLst>
-  </p:timing>
 </p:sld>
 </file>
 
@@ -6901,162 +6121,6 @@
   <p:transition spd="slow">
     <p:push dir="u"/>
   </p:transition>
-  <p:timing>
-    <p:tnLst>
-      <p:par>
-        <p:cTn id="1" dur="indefinite" restart="never" nodeType="tmRoot">
-          <p:childTnLst>
-            <p:seq concurrent="1" nextAc="seek">
-              <p:cTn id="2" dur="indefinite" nodeType="mainSeq">
-                <p:childTnLst>
-                  <p:par>
-                    <p:cTn id="3" fill="hold">
-                      <p:stCondLst>
-                        <p:cond delay="indefinite"/>
-                        <p:cond evt="onBegin" delay="0">
-                          <p:tn val="2"/>
-                        </p:cond>
-                      </p:stCondLst>
-                      <p:childTnLst>
-                        <p:par>
-                          <p:cTn id="4" fill="hold">
-                            <p:stCondLst>
-                              <p:cond delay="500"/>
-                            </p:stCondLst>
-                            <p:childTnLst>
-                              <p:par>
-                                <p:cTn id="10" presetID="10" presetClass="entr" presetSubtype="0" fill="hold" nodeType="withEffect">
-                                  <p:stCondLst>
-                                    <p:cond delay="0"/>
-                                  </p:stCondLst>
-                                  <p:childTnLst>
-                                    <p:set>
-                                      <p:cBhvr>
-                                        <p:cTn id="11" dur="1" fill="hold">
-                                          <p:stCondLst>
-                                            <p:cond delay="0"/>
-                                          </p:stCondLst>
-                                        </p:cTn>
-                                        <p:tgtEl>
-                                          <p:spTgt spid="3"/>
-                                        </p:tgtEl>
-                                        <p:attrNameLst>
-                                          <p:attrName>style.visibility</p:attrName>
-                                        </p:attrNameLst>
-                                      </p:cBhvr>
-                                      <p:to>
-                                        <p:strVal val="visible"/>
-                                      </p:to>
-                                    </p:set>
-                                    <p:animEffect transition="in" filter="fade">
-                                      <p:cBhvr>
-                                        <p:cTn id="12" dur="700"/>
-                                        <p:tgtEl>
-                                          <p:spTgt spid="3"/>
-                                        </p:tgtEl>
-                                      </p:cBhvr>
-                                    </p:animEffect>
-                                  </p:childTnLst>
-                                </p:cTn>
-                              </p:par>
-                              <p:par>
-                                <p:cTn id="13" presetID="10" presetClass="entr" presetSubtype="0" fill="hold" nodeType="withEffect">
-                                  <p:stCondLst>
-                                    <p:cond delay="0"/>
-                                  </p:stCondLst>
-                                  <p:childTnLst>
-                                    <p:set>
-                                      <p:cBhvr>
-                                        <p:cTn id="14" dur="1" fill="hold">
-                                          <p:stCondLst>
-                                            <p:cond delay="0"/>
-                                          </p:stCondLst>
-                                        </p:cTn>
-                                        <p:tgtEl>
-                                          <p:spTgt spid="4"/>
-                                        </p:tgtEl>
-                                        <p:attrNameLst>
-                                          <p:attrName>style.visibility</p:attrName>
-                                        </p:attrNameLst>
-                                      </p:cBhvr>
-                                      <p:to>
-                                        <p:strVal val="visible"/>
-                                      </p:to>
-                                    </p:set>
-                                    <p:animEffect transition="in" filter="fade">
-                                      <p:cBhvr>
-                                        <p:cTn id="15" dur="700"/>
-                                        <p:tgtEl>
-                                          <p:spTgt spid="4"/>
-                                        </p:tgtEl>
-                                      </p:cBhvr>
-                                    </p:animEffect>
-                                  </p:childTnLst>
-                                </p:cTn>
-                              </p:par>
-                              <p:par>
-                                <p:cTn id="16" presetID="10" presetClass="entr" presetSubtype="0" fill="hold" nodeType="withEffect">
-                                  <p:stCondLst>
-                                    <p:cond delay="0"/>
-                                  </p:stCondLst>
-                                  <p:childTnLst>
-                                    <p:set>
-                                      <p:cBhvr>
-                                        <p:cTn id="17" dur="1" fill="hold">
-                                          <p:stCondLst>
-                                            <p:cond delay="0"/>
-                                          </p:stCondLst>
-                                        </p:cTn>
-                                        <p:tgtEl>
-                                          <p:spTgt spid="5"/>
-                                        </p:tgtEl>
-                                        <p:attrNameLst>
-                                          <p:attrName>style.visibility</p:attrName>
-                                        </p:attrNameLst>
-                                      </p:cBhvr>
-                                      <p:to>
-                                        <p:strVal val="visible"/>
-                                      </p:to>
-                                    </p:set>
-                                    <p:animEffect transition="in" filter="fade">
-                                      <p:cBhvr>
-                                        <p:cTn id="18" dur="700"/>
-                                        <p:tgtEl>
-                                          <p:spTgt spid="5"/>
-                                        </p:tgtEl>
-                                      </p:cBhvr>
-                                    </p:animEffect>
-                                  </p:childTnLst>
-                                </p:cTn>
-                              </p:par>
-                            </p:childTnLst>
-                          </p:cTn>
-                        </p:par>
-                      </p:childTnLst>
-                    </p:cTn>
-                  </p:par>
-                </p:childTnLst>
-              </p:cTn>
-              <p:prevCondLst>
-                <p:cond evt="onPrev" delay="0">
-                  <p:tgtEl>
-                    <p:sldTgt/>
-                  </p:tgtEl>
-                </p:cond>
-              </p:prevCondLst>
-              <p:nextCondLst>
-                <p:cond evt="onNext" delay="0">
-                  <p:tgtEl>
-                    <p:sldTgt/>
-                  </p:tgtEl>
-                </p:cond>
-              </p:nextCondLst>
-            </p:seq>
-          </p:childTnLst>
-        </p:cTn>
-      </p:par>
-    </p:tnLst>
-  </p:timing>
 </p:sld>
 </file>
 
@@ -7223,162 +6287,6 @@
   <p:transition spd="med">
     <p:fade/>
   </p:transition>
-  <p:timing>
-    <p:tnLst>
-      <p:par>
-        <p:cTn id="1" dur="indefinite" restart="never" nodeType="tmRoot">
-          <p:childTnLst>
-            <p:seq concurrent="1" nextAc="seek">
-              <p:cTn id="2" dur="indefinite" nodeType="mainSeq">
-                <p:childTnLst>
-                  <p:par>
-                    <p:cTn id="3" fill="hold">
-                      <p:stCondLst>
-                        <p:cond delay="indefinite"/>
-                        <p:cond evt="onBegin" delay="0">
-                          <p:tn val="2"/>
-                        </p:cond>
-                      </p:stCondLst>
-                      <p:childTnLst>
-                        <p:par>
-                          <p:cTn id="4" fill="hold">
-                            <p:stCondLst>
-                              <p:cond delay="500"/>
-                            </p:stCondLst>
-                            <p:childTnLst>
-                              <p:par>
-                                <p:cTn id="10" presetID="10" presetClass="entr" presetSubtype="0" fill="hold" nodeType="withEffect">
-                                  <p:stCondLst>
-                                    <p:cond delay="0"/>
-                                  </p:stCondLst>
-                                  <p:childTnLst>
-                                    <p:set>
-                                      <p:cBhvr>
-                                        <p:cTn id="11" dur="1" fill="hold">
-                                          <p:stCondLst>
-                                            <p:cond delay="0"/>
-                                          </p:stCondLst>
-                                        </p:cTn>
-                                        <p:tgtEl>
-                                          <p:spTgt spid="3"/>
-                                        </p:tgtEl>
-                                        <p:attrNameLst>
-                                          <p:attrName>style.visibility</p:attrName>
-                                        </p:attrNameLst>
-                                      </p:cBhvr>
-                                      <p:to>
-                                        <p:strVal val="visible"/>
-                                      </p:to>
-                                    </p:set>
-                                    <p:animEffect transition="in" filter="fade">
-                                      <p:cBhvr>
-                                        <p:cTn id="12" dur="700"/>
-                                        <p:tgtEl>
-                                          <p:spTgt spid="3"/>
-                                        </p:tgtEl>
-                                      </p:cBhvr>
-                                    </p:animEffect>
-                                  </p:childTnLst>
-                                </p:cTn>
-                              </p:par>
-                              <p:par>
-                                <p:cTn id="13" presetID="10" presetClass="entr" presetSubtype="0" fill="hold" nodeType="withEffect">
-                                  <p:stCondLst>
-                                    <p:cond delay="0"/>
-                                  </p:stCondLst>
-                                  <p:childTnLst>
-                                    <p:set>
-                                      <p:cBhvr>
-                                        <p:cTn id="14" dur="1" fill="hold">
-                                          <p:stCondLst>
-                                            <p:cond delay="0"/>
-                                          </p:stCondLst>
-                                        </p:cTn>
-                                        <p:tgtEl>
-                                          <p:spTgt spid="4"/>
-                                        </p:tgtEl>
-                                        <p:attrNameLst>
-                                          <p:attrName>style.visibility</p:attrName>
-                                        </p:attrNameLst>
-                                      </p:cBhvr>
-                                      <p:to>
-                                        <p:strVal val="visible"/>
-                                      </p:to>
-                                    </p:set>
-                                    <p:animEffect transition="in" filter="fade">
-                                      <p:cBhvr>
-                                        <p:cTn id="15" dur="700"/>
-                                        <p:tgtEl>
-                                          <p:spTgt spid="4"/>
-                                        </p:tgtEl>
-                                      </p:cBhvr>
-                                    </p:animEffect>
-                                  </p:childTnLst>
-                                </p:cTn>
-                              </p:par>
-                              <p:par>
-                                <p:cTn id="16" presetID="10" presetClass="entr" presetSubtype="0" fill="hold" nodeType="withEffect">
-                                  <p:stCondLst>
-                                    <p:cond delay="0"/>
-                                  </p:stCondLst>
-                                  <p:childTnLst>
-                                    <p:set>
-                                      <p:cBhvr>
-                                        <p:cTn id="17" dur="1" fill="hold">
-                                          <p:stCondLst>
-                                            <p:cond delay="0"/>
-                                          </p:stCondLst>
-                                        </p:cTn>
-                                        <p:tgtEl>
-                                          <p:spTgt spid="5"/>
-                                        </p:tgtEl>
-                                        <p:attrNameLst>
-                                          <p:attrName>style.visibility</p:attrName>
-                                        </p:attrNameLst>
-                                      </p:cBhvr>
-                                      <p:to>
-                                        <p:strVal val="visible"/>
-                                      </p:to>
-                                    </p:set>
-                                    <p:animEffect transition="in" filter="fade">
-                                      <p:cBhvr>
-                                        <p:cTn id="18" dur="700"/>
-                                        <p:tgtEl>
-                                          <p:spTgt spid="5"/>
-                                        </p:tgtEl>
-                                      </p:cBhvr>
-                                    </p:animEffect>
-                                  </p:childTnLst>
-                                </p:cTn>
-                              </p:par>
-                            </p:childTnLst>
-                          </p:cTn>
-                        </p:par>
-                      </p:childTnLst>
-                    </p:cTn>
-                  </p:par>
-                </p:childTnLst>
-              </p:cTn>
-              <p:prevCondLst>
-                <p:cond evt="onPrev" delay="0">
-                  <p:tgtEl>
-                    <p:sldTgt/>
-                  </p:tgtEl>
-                </p:cond>
-              </p:prevCondLst>
-              <p:nextCondLst>
-                <p:cond evt="onNext" delay="0">
-                  <p:tgtEl>
-                    <p:sldTgt/>
-                  </p:tgtEl>
-                </p:cond>
-              </p:nextCondLst>
-            </p:seq>
-          </p:childTnLst>
-        </p:cTn>
-      </p:par>
-    </p:tnLst>
-  </p:timing>
 </p:sld>
 </file>
 
@@ -7545,162 +6453,6 @@
   <p:transition spd="med">
     <p:fade/>
   </p:transition>
-  <p:timing>
-    <p:tnLst>
-      <p:par>
-        <p:cTn id="1" dur="indefinite" restart="never" nodeType="tmRoot">
-          <p:childTnLst>
-            <p:seq concurrent="1" nextAc="seek">
-              <p:cTn id="2" dur="indefinite" nodeType="mainSeq">
-                <p:childTnLst>
-                  <p:par>
-                    <p:cTn id="3" fill="hold">
-                      <p:stCondLst>
-                        <p:cond delay="indefinite"/>
-                        <p:cond evt="onBegin" delay="0">
-                          <p:tn val="2"/>
-                        </p:cond>
-                      </p:stCondLst>
-                      <p:childTnLst>
-                        <p:par>
-                          <p:cTn id="4" fill="hold">
-                            <p:stCondLst>
-                              <p:cond delay="500"/>
-                            </p:stCondLst>
-                            <p:childTnLst>
-                              <p:par>
-                                <p:cTn id="10" presetID="10" presetClass="entr" presetSubtype="0" fill="hold" nodeType="withEffect">
-                                  <p:stCondLst>
-                                    <p:cond delay="0"/>
-                                  </p:stCondLst>
-                                  <p:childTnLst>
-                                    <p:set>
-                                      <p:cBhvr>
-                                        <p:cTn id="11" dur="1" fill="hold">
-                                          <p:stCondLst>
-                                            <p:cond delay="0"/>
-                                          </p:stCondLst>
-                                        </p:cTn>
-                                        <p:tgtEl>
-                                          <p:spTgt spid="3"/>
-                                        </p:tgtEl>
-                                        <p:attrNameLst>
-                                          <p:attrName>style.visibility</p:attrName>
-                                        </p:attrNameLst>
-                                      </p:cBhvr>
-                                      <p:to>
-                                        <p:strVal val="visible"/>
-                                      </p:to>
-                                    </p:set>
-                                    <p:animEffect transition="in" filter="fade">
-                                      <p:cBhvr>
-                                        <p:cTn id="12" dur="700"/>
-                                        <p:tgtEl>
-                                          <p:spTgt spid="3"/>
-                                        </p:tgtEl>
-                                      </p:cBhvr>
-                                    </p:animEffect>
-                                  </p:childTnLst>
-                                </p:cTn>
-                              </p:par>
-                              <p:par>
-                                <p:cTn id="13" presetID="10" presetClass="entr" presetSubtype="0" fill="hold" nodeType="withEffect">
-                                  <p:stCondLst>
-                                    <p:cond delay="0"/>
-                                  </p:stCondLst>
-                                  <p:childTnLst>
-                                    <p:set>
-                                      <p:cBhvr>
-                                        <p:cTn id="14" dur="1" fill="hold">
-                                          <p:stCondLst>
-                                            <p:cond delay="0"/>
-                                          </p:stCondLst>
-                                        </p:cTn>
-                                        <p:tgtEl>
-                                          <p:spTgt spid="4"/>
-                                        </p:tgtEl>
-                                        <p:attrNameLst>
-                                          <p:attrName>style.visibility</p:attrName>
-                                        </p:attrNameLst>
-                                      </p:cBhvr>
-                                      <p:to>
-                                        <p:strVal val="visible"/>
-                                      </p:to>
-                                    </p:set>
-                                    <p:animEffect transition="in" filter="fade">
-                                      <p:cBhvr>
-                                        <p:cTn id="15" dur="700"/>
-                                        <p:tgtEl>
-                                          <p:spTgt spid="4"/>
-                                        </p:tgtEl>
-                                      </p:cBhvr>
-                                    </p:animEffect>
-                                  </p:childTnLst>
-                                </p:cTn>
-                              </p:par>
-                              <p:par>
-                                <p:cTn id="16" presetID="10" presetClass="entr" presetSubtype="0" fill="hold" nodeType="withEffect">
-                                  <p:stCondLst>
-                                    <p:cond delay="0"/>
-                                  </p:stCondLst>
-                                  <p:childTnLst>
-                                    <p:set>
-                                      <p:cBhvr>
-                                        <p:cTn id="17" dur="1" fill="hold">
-                                          <p:stCondLst>
-                                            <p:cond delay="0"/>
-                                          </p:stCondLst>
-                                        </p:cTn>
-                                        <p:tgtEl>
-                                          <p:spTgt spid="5"/>
-                                        </p:tgtEl>
-                                        <p:attrNameLst>
-                                          <p:attrName>style.visibility</p:attrName>
-                                        </p:attrNameLst>
-                                      </p:cBhvr>
-                                      <p:to>
-                                        <p:strVal val="visible"/>
-                                      </p:to>
-                                    </p:set>
-                                    <p:animEffect transition="in" filter="fade">
-                                      <p:cBhvr>
-                                        <p:cTn id="18" dur="700"/>
-                                        <p:tgtEl>
-                                          <p:spTgt spid="5"/>
-                                        </p:tgtEl>
-                                      </p:cBhvr>
-                                    </p:animEffect>
-                                  </p:childTnLst>
-                                </p:cTn>
-                              </p:par>
-                            </p:childTnLst>
-                          </p:cTn>
-                        </p:par>
-                      </p:childTnLst>
-                    </p:cTn>
-                  </p:par>
-                </p:childTnLst>
-              </p:cTn>
-              <p:prevCondLst>
-                <p:cond evt="onPrev" delay="0">
-                  <p:tgtEl>
-                    <p:sldTgt/>
-                  </p:tgtEl>
-                </p:cond>
-              </p:prevCondLst>
-              <p:nextCondLst>
-                <p:cond evt="onNext" delay="0">
-                  <p:tgtEl>
-                    <p:sldTgt/>
-                  </p:tgtEl>
-                </p:cond>
-              </p:nextCondLst>
-            </p:seq>
-          </p:childTnLst>
-        </p:cTn>
-      </p:par>
-    </p:tnLst>
-  </p:timing>
 </p:sld>
 </file>
 
@@ -7867,162 +6619,6 @@
   <p:transition spd="med">
     <p:fade/>
   </p:transition>
-  <p:timing>
-    <p:tnLst>
-      <p:par>
-        <p:cTn id="1" dur="indefinite" restart="never" nodeType="tmRoot">
-          <p:childTnLst>
-            <p:seq concurrent="1" nextAc="seek">
-              <p:cTn id="2" dur="indefinite" nodeType="mainSeq">
-                <p:childTnLst>
-                  <p:par>
-                    <p:cTn id="3" fill="hold">
-                      <p:stCondLst>
-                        <p:cond delay="indefinite"/>
-                        <p:cond evt="onBegin" delay="0">
-                          <p:tn val="2"/>
-                        </p:cond>
-                      </p:stCondLst>
-                      <p:childTnLst>
-                        <p:par>
-                          <p:cTn id="4" fill="hold">
-                            <p:stCondLst>
-                              <p:cond delay="500"/>
-                            </p:stCondLst>
-                            <p:childTnLst>
-                              <p:par>
-                                <p:cTn id="10" presetID="10" presetClass="entr" presetSubtype="0" fill="hold" nodeType="withEffect">
-                                  <p:stCondLst>
-                                    <p:cond delay="0"/>
-                                  </p:stCondLst>
-                                  <p:childTnLst>
-                                    <p:set>
-                                      <p:cBhvr>
-                                        <p:cTn id="11" dur="1" fill="hold">
-                                          <p:stCondLst>
-                                            <p:cond delay="0"/>
-                                          </p:stCondLst>
-                                        </p:cTn>
-                                        <p:tgtEl>
-                                          <p:spTgt spid="3"/>
-                                        </p:tgtEl>
-                                        <p:attrNameLst>
-                                          <p:attrName>style.visibility</p:attrName>
-                                        </p:attrNameLst>
-                                      </p:cBhvr>
-                                      <p:to>
-                                        <p:strVal val="visible"/>
-                                      </p:to>
-                                    </p:set>
-                                    <p:animEffect transition="in" filter="fade">
-                                      <p:cBhvr>
-                                        <p:cTn id="12" dur="700"/>
-                                        <p:tgtEl>
-                                          <p:spTgt spid="3"/>
-                                        </p:tgtEl>
-                                      </p:cBhvr>
-                                    </p:animEffect>
-                                  </p:childTnLst>
-                                </p:cTn>
-                              </p:par>
-                              <p:par>
-                                <p:cTn id="13" presetID="10" presetClass="entr" presetSubtype="0" fill="hold" nodeType="withEffect">
-                                  <p:stCondLst>
-                                    <p:cond delay="0"/>
-                                  </p:stCondLst>
-                                  <p:childTnLst>
-                                    <p:set>
-                                      <p:cBhvr>
-                                        <p:cTn id="14" dur="1" fill="hold">
-                                          <p:stCondLst>
-                                            <p:cond delay="0"/>
-                                          </p:stCondLst>
-                                        </p:cTn>
-                                        <p:tgtEl>
-                                          <p:spTgt spid="4"/>
-                                        </p:tgtEl>
-                                        <p:attrNameLst>
-                                          <p:attrName>style.visibility</p:attrName>
-                                        </p:attrNameLst>
-                                      </p:cBhvr>
-                                      <p:to>
-                                        <p:strVal val="visible"/>
-                                      </p:to>
-                                    </p:set>
-                                    <p:animEffect transition="in" filter="fade">
-                                      <p:cBhvr>
-                                        <p:cTn id="15" dur="700"/>
-                                        <p:tgtEl>
-                                          <p:spTgt spid="4"/>
-                                        </p:tgtEl>
-                                      </p:cBhvr>
-                                    </p:animEffect>
-                                  </p:childTnLst>
-                                </p:cTn>
-                              </p:par>
-                              <p:par>
-                                <p:cTn id="16" presetID="10" presetClass="entr" presetSubtype="0" fill="hold" nodeType="withEffect">
-                                  <p:stCondLst>
-                                    <p:cond delay="0"/>
-                                  </p:stCondLst>
-                                  <p:childTnLst>
-                                    <p:set>
-                                      <p:cBhvr>
-                                        <p:cTn id="17" dur="1" fill="hold">
-                                          <p:stCondLst>
-                                            <p:cond delay="0"/>
-                                          </p:stCondLst>
-                                        </p:cTn>
-                                        <p:tgtEl>
-                                          <p:spTgt spid="5"/>
-                                        </p:tgtEl>
-                                        <p:attrNameLst>
-                                          <p:attrName>style.visibility</p:attrName>
-                                        </p:attrNameLst>
-                                      </p:cBhvr>
-                                      <p:to>
-                                        <p:strVal val="visible"/>
-                                      </p:to>
-                                    </p:set>
-                                    <p:animEffect transition="in" filter="fade">
-                                      <p:cBhvr>
-                                        <p:cTn id="18" dur="700"/>
-                                        <p:tgtEl>
-                                          <p:spTgt spid="5"/>
-                                        </p:tgtEl>
-                                      </p:cBhvr>
-                                    </p:animEffect>
-                                  </p:childTnLst>
-                                </p:cTn>
-                              </p:par>
-                            </p:childTnLst>
-                          </p:cTn>
-                        </p:par>
-                      </p:childTnLst>
-                    </p:cTn>
-                  </p:par>
-                </p:childTnLst>
-              </p:cTn>
-              <p:prevCondLst>
-                <p:cond evt="onPrev" delay="0">
-                  <p:tgtEl>
-                    <p:sldTgt/>
-                  </p:tgtEl>
-                </p:cond>
-              </p:prevCondLst>
-              <p:nextCondLst>
-                <p:cond evt="onNext" delay="0">
-                  <p:tgtEl>
-                    <p:sldTgt/>
-                  </p:tgtEl>
-                </p:cond>
-              </p:nextCondLst>
-            </p:seq>
-          </p:childTnLst>
-        </p:cTn>
-      </p:par>
-    </p:tnLst>
-  </p:timing>
 </p:sld>
 </file>
 

</xml_diff>